<commit_message>
v4.3.2: CEO + CTO decks updated with PaperBanana diagrams
CEO Deck: 11 PaperBanana diagrams inserted across slides 4-17
- Ecosystem overview, Pi Brain, AIMDS security, compression pipeline
- Speed comparison, Ruflo team, deployment options

CTO Deck: 13 PaperBanana diagrams inserted across slides 3-18
- Architecture, HNSW speed, RVF format, AIMDS security
- SONA learning, RuVector, MinCut, benchmarks, integration

Images: hero-ecosystem, story-ruflo-team, story-ruvector-library,
story-pi-brain, story-aimds-security, deck-compression,
deck-speed-comparison, deck-topologies, card-ruflo, card-ruvector,
card-pi, card-aimds

Co-Authored-By: Claude Opus 4.6 (1M context) <noreply@anthropic.com>
</commit_message>
<xml_diff>
--- a/src/ui/public/assets/docs/CEO-Deck-RuvNet-2026.pptx
+++ b/src/ui/public/assets/docs/CEO-Deck-RuvNet-2026.pptx
@@ -2496,6 +2496,10 @@
           </a:solidFill>
           <a:ln/>
         </p:spPr>
+        <p:txBody>
+          <a:bodyPr/>
+          <a:p/>
+        </p:txBody>
       </p:sp>
       <p:pic>
         <p:nvPicPr>
@@ -3076,6 +3080,10 @@
           </a:solidFill>
           <a:ln/>
         </p:spPr>
+        <p:txBody>
+          <a:bodyPr/>
+          <a:p/>
+        </p:txBody>
       </p:sp>
       <p:sp>
         <p:nvSpPr>
@@ -3198,6 +3206,10 @@
             </a:outerShdw>
           </a:effectLst>
         </p:spPr>
+        <p:txBody>
+          <a:bodyPr/>
+          <a:p/>
+        </p:txBody>
       </p:sp>
       <p:sp>
         <p:nvSpPr>
@@ -3218,6 +3230,10 @@
           </a:solidFill>
           <a:ln/>
         </p:spPr>
+        <p:txBody>
+          <a:bodyPr/>
+          <a:p/>
+        </p:txBody>
       </p:sp>
       <p:sp>
         <p:nvSpPr>
@@ -3238,6 +3254,10 @@
           </a:solidFill>
           <a:ln/>
         </p:spPr>
+        <p:txBody>
+          <a:bodyPr/>
+          <a:p/>
+        </p:txBody>
       </p:sp>
       <p:sp>
         <p:nvSpPr>
@@ -3392,6 +3412,10 @@
           </a:solidFill>
           <a:ln/>
         </p:spPr>
+        <p:txBody>
+          <a:bodyPr/>
+          <a:p/>
+        </p:txBody>
       </p:sp>
       <p:sp>
         <p:nvSpPr>
@@ -3507,6 +3531,10 @@
           </a:solidFill>
           <a:ln/>
         </p:spPr>
+        <p:txBody>
+          <a:bodyPr/>
+          <a:p/>
+        </p:txBody>
       </p:sp>
       <p:sp>
         <p:nvSpPr>
@@ -3573,6 +3601,10 @@
             </a:outerShdw>
           </a:effectLst>
         </p:spPr>
+        <p:txBody>
+          <a:bodyPr/>
+          <a:p/>
+        </p:txBody>
       </p:sp>
       <p:sp>
         <p:nvSpPr>
@@ -3593,6 +3625,10 @@
           </a:solidFill>
           <a:ln/>
         </p:spPr>
+        <p:txBody>
+          <a:bodyPr/>
+          <a:p/>
+        </p:txBody>
       </p:sp>
       <p:sp>
         <p:nvSpPr>
@@ -3737,6 +3773,10 @@
             </a:outerShdw>
           </a:effectLst>
         </p:spPr>
+        <p:txBody>
+          <a:bodyPr/>
+          <a:p/>
+        </p:txBody>
       </p:sp>
       <p:sp>
         <p:nvSpPr>
@@ -3757,6 +3797,10 @@
           </a:solidFill>
           <a:ln/>
         </p:spPr>
+        <p:txBody>
+          <a:bodyPr/>
+          <a:p/>
+        </p:txBody>
       </p:sp>
       <p:sp>
         <p:nvSpPr>
@@ -3901,6 +3945,10 @@
             </a:outerShdw>
           </a:effectLst>
         </p:spPr>
+        <p:txBody>
+          <a:bodyPr/>
+          <a:p/>
+        </p:txBody>
       </p:sp>
       <p:sp>
         <p:nvSpPr>
@@ -3921,6 +3969,10 @@
           </a:solidFill>
           <a:ln/>
         </p:spPr>
+        <p:txBody>
+          <a:bodyPr/>
+          <a:p/>
+        </p:txBody>
       </p:sp>
       <p:sp>
         <p:nvSpPr>
@@ -4065,6 +4117,10 @@
             </a:outerShdw>
           </a:effectLst>
         </p:spPr>
+        <p:txBody>
+          <a:bodyPr/>
+          <a:p/>
+        </p:txBody>
       </p:sp>
       <p:sp>
         <p:nvSpPr>
@@ -4085,6 +4141,10 @@
           </a:solidFill>
           <a:ln/>
         </p:spPr>
+        <p:txBody>
+          <a:bodyPr/>
+          <a:p/>
+        </p:txBody>
       </p:sp>
       <p:sp>
         <p:nvSpPr>
@@ -4203,6 +4263,30 @@
           </a:p>
         </p:txBody>
       </p:sp>
+      <p:pic>
+        <p:nvPicPr>
+          <p:cNvPr id="36" name="Picture 35" descr="story-ruflo-team.png"/>
+          <p:cNvPicPr>
+            <a:picLocks noChangeAspect="1"/>
+          </p:cNvPicPr>
+          <p:nvPr/>
+        </p:nvPicPr>
+        <p:blipFill>
+          <a:blip r:embed="rId3"/>
+          <a:stretch>
+            <a:fillRect/>
+          </a:stretch>
+        </p:blipFill>
+        <p:spPr>
+          <a:xfrm>
+            <a:off x="5029200" y="1371600"/>
+            <a:ext cx="3840480" cy="2560320"/>
+          </a:xfrm>
+          <a:prstGeom prst="rect">
+            <a:avLst/>
+          </a:prstGeom>
+        </p:spPr>
+      </p:pic>
     </p:spTree>
   </p:cSld>
   <p:clrMapOvr>
@@ -4254,6 +4338,10 @@
           </a:solidFill>
           <a:ln/>
         </p:spPr>
+        <p:txBody>
+          <a:bodyPr/>
+          <a:p/>
+        </p:txBody>
       </p:sp>
       <p:sp>
         <p:nvSpPr>
@@ -4337,6 +4425,10 @@
             </a:outerShdw>
           </a:effectLst>
         </p:spPr>
+        <p:txBody>
+          <a:bodyPr/>
+          <a:p/>
+        </p:txBody>
       </p:sp>
       <p:sp>
         <p:nvSpPr>
@@ -4357,6 +4449,10 @@
           </a:solidFill>
           <a:ln/>
         </p:spPr>
+        <p:txBody>
+          <a:bodyPr/>
+          <a:p/>
+        </p:txBody>
       </p:sp>
       <p:sp>
         <p:nvSpPr>
@@ -4611,6 +4707,10 @@
           </a:solidFill>
           <a:ln/>
         </p:spPr>
+        <p:txBody>
+          <a:bodyPr/>
+          <a:p/>
+        </p:txBody>
       </p:sp>
       <p:sp>
         <p:nvSpPr>
@@ -4677,6 +4777,10 @@
             </a:outerShdw>
           </a:effectLst>
         </p:spPr>
+        <p:txBody>
+          <a:bodyPr/>
+          <a:p/>
+        </p:txBody>
       </p:sp>
       <p:sp>
         <p:nvSpPr>
@@ -4697,6 +4801,10 @@
           </a:solidFill>
           <a:ln/>
         </p:spPr>
+        <p:txBody>
+          <a:bodyPr/>
+          <a:p/>
+        </p:txBody>
       </p:sp>
       <p:sp>
         <p:nvSpPr>
@@ -4951,6 +5059,10 @@
           </a:solidFill>
           <a:ln/>
         </p:spPr>
+        <p:txBody>
+          <a:bodyPr/>
+          <a:p/>
+        </p:txBody>
       </p:sp>
       <p:sp>
         <p:nvSpPr>
@@ -5017,6 +5129,10 @@
             </a:outerShdw>
           </a:effectLst>
         </p:spPr>
+        <p:txBody>
+          <a:bodyPr/>
+          <a:p/>
+        </p:txBody>
       </p:sp>
       <p:sp>
         <p:nvSpPr>
@@ -5037,6 +5153,10 @@
           </a:solidFill>
           <a:ln/>
         </p:spPr>
+        <p:txBody>
+          <a:bodyPr/>
+          <a:p/>
+        </p:txBody>
       </p:sp>
       <p:sp>
         <p:nvSpPr>
@@ -5291,6 +5411,10 @@
           </a:solidFill>
           <a:ln/>
         </p:spPr>
+        <p:txBody>
+          <a:bodyPr/>
+          <a:p/>
+        </p:txBody>
       </p:sp>
       <p:sp>
         <p:nvSpPr>
@@ -5357,6 +5481,10 @@
             </a:outerShdw>
           </a:effectLst>
         </p:spPr>
+        <p:txBody>
+          <a:bodyPr/>
+          <a:p/>
+        </p:txBody>
       </p:sp>
       <p:sp>
         <p:nvSpPr>
@@ -5377,6 +5505,10 @@
           </a:solidFill>
           <a:ln/>
         </p:spPr>
+        <p:txBody>
+          <a:bodyPr/>
+          <a:p/>
+        </p:txBody>
       </p:sp>
       <p:sp>
         <p:nvSpPr>
@@ -5631,6 +5763,10 @@
           </a:solidFill>
           <a:ln/>
         </p:spPr>
+        <p:txBody>
+          <a:bodyPr/>
+          <a:p/>
+        </p:txBody>
       </p:sp>
       <p:sp>
         <p:nvSpPr>
@@ -5761,6 +5897,10 @@
           </a:solidFill>
           <a:ln/>
         </p:spPr>
+        <p:txBody>
+          <a:bodyPr/>
+          <a:p/>
+        </p:txBody>
       </p:sp>
       <p:sp>
         <p:nvSpPr>
@@ -5827,6 +5967,10 @@
             </a:outerShdw>
           </a:effectLst>
         </p:spPr>
+        <p:txBody>
+          <a:bodyPr/>
+          <a:p/>
+        </p:txBody>
       </p:sp>
       <p:sp>
         <p:nvSpPr>
@@ -5847,6 +5991,10 @@
           </a:solidFill>
           <a:ln/>
         </p:spPr>
+        <p:txBody>
+          <a:bodyPr/>
+          <a:p/>
+        </p:txBody>
       </p:sp>
       <p:sp>
         <p:nvSpPr>
@@ -6082,6 +6230,10 @@
             </a:outerShdw>
           </a:effectLst>
         </p:spPr>
+        <p:txBody>
+          <a:bodyPr/>
+          <a:p/>
+        </p:txBody>
       </p:sp>
       <p:sp>
         <p:nvSpPr>
@@ -6102,6 +6254,10 @@
           </a:solidFill>
           <a:ln/>
         </p:spPr>
+        <p:txBody>
+          <a:bodyPr/>
+          <a:p/>
+        </p:txBody>
       </p:sp>
       <p:sp>
         <p:nvSpPr>
@@ -6330,6 +6486,10 @@
           </a:solidFill>
           <a:ln/>
         </p:spPr>
+        <p:txBody>
+          <a:bodyPr/>
+          <a:p/>
+        </p:txBody>
       </p:sp>
       <p:sp>
         <p:nvSpPr>
@@ -6370,6 +6530,30 @@
           </a:p>
         </p:txBody>
       </p:sp>
+      <p:pic>
+        <p:nvPicPr>
+          <p:cNvPr id="14" name="Picture 13" descr="story-ruflo-team.png"/>
+          <p:cNvPicPr>
+            <a:picLocks noChangeAspect="1"/>
+          </p:cNvPicPr>
+          <p:nvPr/>
+        </p:nvPicPr>
+        <p:blipFill>
+          <a:blip r:embed="rId3"/>
+          <a:stretch>
+            <a:fillRect/>
+          </a:stretch>
+        </p:blipFill>
+        <p:spPr>
+          <a:xfrm>
+            <a:off x="5029200" y="1371600"/>
+            <a:ext cx="3840480" cy="2560320"/>
+          </a:xfrm>
+          <a:prstGeom prst="rect">
+            <a:avLst/>
+          </a:prstGeom>
+        </p:spPr>
+      </p:pic>
     </p:spTree>
   </p:cSld>
   <p:clrMapOvr>
@@ -6421,6 +6605,10 @@
           </a:solidFill>
           <a:ln/>
         </p:spPr>
+        <p:txBody>
+          <a:bodyPr/>
+          <a:p/>
+        </p:txBody>
       </p:sp>
       <p:sp>
         <p:nvSpPr>
@@ -6552,6 +6740,10 @@
             </a:outerShdw>
           </a:effectLst>
         </p:spPr>
+        <p:txBody>
+          <a:bodyPr/>
+          <a:p/>
+        </p:txBody>
       </p:sp>
       <p:sp>
         <p:nvSpPr>
@@ -6572,6 +6764,10 @@
           </a:solidFill>
           <a:ln/>
         </p:spPr>
+        <p:txBody>
+          <a:bodyPr/>
+          <a:p/>
+        </p:txBody>
       </p:sp>
       <p:sp>
         <p:nvSpPr>
@@ -6677,6 +6873,10 @@
             </a:outerShdw>
           </a:effectLst>
         </p:spPr>
+        <p:txBody>
+          <a:bodyPr/>
+          <a:p/>
+        </p:txBody>
       </p:sp>
       <p:sp>
         <p:nvSpPr>
@@ -6697,6 +6897,10 @@
           </a:solidFill>
           <a:ln/>
         </p:spPr>
+        <p:txBody>
+          <a:bodyPr/>
+          <a:p/>
+        </p:txBody>
       </p:sp>
       <p:sp>
         <p:nvSpPr>
@@ -6802,6 +7006,10 @@
             </a:outerShdw>
           </a:effectLst>
         </p:spPr>
+        <p:txBody>
+          <a:bodyPr/>
+          <a:p/>
+        </p:txBody>
       </p:sp>
       <p:sp>
         <p:nvSpPr>
@@ -6822,6 +7030,10 @@
           </a:solidFill>
           <a:ln/>
         </p:spPr>
+        <p:txBody>
+          <a:bodyPr/>
+          <a:p/>
+        </p:txBody>
       </p:sp>
       <p:sp>
         <p:nvSpPr>
@@ -6927,6 +7139,10 @@
             </a:outerShdw>
           </a:effectLst>
         </p:spPr>
+        <p:txBody>
+          <a:bodyPr/>
+          <a:p/>
+        </p:txBody>
       </p:sp>
       <p:sp>
         <p:nvSpPr>
@@ -6947,6 +7163,10 @@
           </a:solidFill>
           <a:ln/>
         </p:spPr>
+        <p:txBody>
+          <a:bodyPr/>
+          <a:p/>
+        </p:txBody>
       </p:sp>
       <p:sp>
         <p:nvSpPr>
@@ -7045,6 +7265,10 @@
           </a:solidFill>
           <a:ln/>
         </p:spPr>
+        <p:txBody>
+          <a:bodyPr/>
+          <a:p/>
+        </p:txBody>
       </p:sp>
       <p:sp>
         <p:nvSpPr>
@@ -7085,6 +7309,30 @@
           </a:p>
         </p:txBody>
       </p:sp>
+      <p:pic>
+        <p:nvPicPr>
+          <p:cNvPr id="24" name="Picture 23" descr="story-aimds-security.png"/>
+          <p:cNvPicPr>
+            <a:picLocks noChangeAspect="1"/>
+          </p:cNvPicPr>
+          <p:nvPr/>
+        </p:nvPicPr>
+        <p:blipFill>
+          <a:blip r:embed="rId4"/>
+          <a:stretch>
+            <a:fillRect/>
+          </a:stretch>
+        </p:blipFill>
+        <p:spPr>
+          <a:xfrm>
+            <a:off x="5029200" y="1371600"/>
+            <a:ext cx="3840480" cy="2560320"/>
+          </a:xfrm>
+          <a:prstGeom prst="rect">
+            <a:avLst/>
+          </a:prstGeom>
+        </p:spPr>
+      </p:pic>
     </p:spTree>
   </p:cSld>
   <p:clrMapOvr>
@@ -7136,6 +7384,10 @@
           </a:solidFill>
           <a:ln/>
         </p:spPr>
+        <p:txBody>
+          <a:bodyPr/>
+          <a:p/>
+        </p:txBody>
       </p:sp>
       <p:sp>
         <p:nvSpPr>
@@ -7202,6 +7454,10 @@
             </a:outerShdw>
           </a:effectLst>
         </p:spPr>
+        <p:txBody>
+          <a:bodyPr/>
+          <a:p/>
+        </p:txBody>
       </p:sp>
       <p:sp>
         <p:nvSpPr>
@@ -7222,6 +7478,10 @@
           </a:solidFill>
           <a:ln/>
         </p:spPr>
+        <p:txBody>
+          <a:bodyPr/>
+          <a:p/>
+        </p:txBody>
       </p:sp>
       <p:sp>
         <p:nvSpPr>
@@ -7373,6 +7633,10 @@
             </a:outerShdw>
           </a:effectLst>
         </p:spPr>
+        <p:txBody>
+          <a:bodyPr/>
+          <a:p/>
+        </p:txBody>
       </p:sp>
       <p:sp>
         <p:nvSpPr>
@@ -7393,6 +7657,10 @@
           </a:solidFill>
           <a:ln/>
         </p:spPr>
+        <p:txBody>
+          <a:bodyPr/>
+          <a:p/>
+        </p:txBody>
       </p:sp>
       <p:sp>
         <p:nvSpPr>
@@ -7544,6 +7812,10 @@
             </a:outerShdw>
           </a:effectLst>
         </p:spPr>
+        <p:txBody>
+          <a:bodyPr/>
+          <a:p/>
+        </p:txBody>
       </p:sp>
       <p:sp>
         <p:nvSpPr>
@@ -7564,6 +7836,10 @@
           </a:solidFill>
           <a:ln/>
         </p:spPr>
+        <p:txBody>
+          <a:bodyPr/>
+          <a:p/>
+        </p:txBody>
       </p:sp>
       <p:sp>
         <p:nvSpPr>
@@ -7715,6 +7991,10 @@
             </a:outerShdw>
           </a:effectLst>
         </p:spPr>
+        <p:txBody>
+          <a:bodyPr/>
+          <a:p/>
+        </p:txBody>
       </p:sp>
       <p:sp>
         <p:nvSpPr>
@@ -7735,6 +8015,10 @@
           </a:solidFill>
           <a:ln/>
         </p:spPr>
+        <p:txBody>
+          <a:bodyPr/>
+          <a:p/>
+        </p:txBody>
       </p:sp>
       <p:sp>
         <p:nvSpPr>
@@ -7860,6 +8144,30 @@
           </a:p>
         </p:txBody>
       </p:sp>
+      <p:pic>
+        <p:nvPicPr>
+          <p:cNvPr id="20" name="Picture 19" descr="story-aimds-security.png"/>
+          <p:cNvPicPr>
+            <a:picLocks noChangeAspect="1"/>
+          </p:cNvPicPr>
+          <p:nvPr/>
+        </p:nvPicPr>
+        <p:blipFill>
+          <a:blip r:embed="rId3"/>
+          <a:stretch>
+            <a:fillRect/>
+          </a:stretch>
+        </p:blipFill>
+        <p:spPr>
+          <a:xfrm>
+            <a:off x="5029200" y="1371600"/>
+            <a:ext cx="3840480" cy="2560320"/>
+          </a:xfrm>
+          <a:prstGeom prst="rect">
+            <a:avLst/>
+          </a:prstGeom>
+        </p:spPr>
+      </p:pic>
     </p:spTree>
   </p:cSld>
   <p:clrMapOvr>
@@ -7911,6 +8219,10 @@
           </a:solidFill>
           <a:ln/>
         </p:spPr>
+        <p:txBody>
+          <a:bodyPr/>
+          <a:p/>
+        </p:txBody>
       </p:sp>
       <p:sp>
         <p:nvSpPr>
@@ -8033,6 +8345,10 @@
             </a:outerShdw>
           </a:effectLst>
         </p:spPr>
+        <p:txBody>
+          <a:bodyPr/>
+          <a:p/>
+        </p:txBody>
       </p:sp>
       <p:sp>
         <p:nvSpPr>
@@ -8053,6 +8369,10 @@
           </a:solidFill>
           <a:ln/>
         </p:spPr>
+        <p:txBody>
+          <a:bodyPr/>
+          <a:p/>
+        </p:txBody>
       </p:sp>
       <p:sp>
         <p:nvSpPr>
@@ -8158,6 +8478,10 @@
             </a:outerShdw>
           </a:effectLst>
         </p:spPr>
+        <p:txBody>
+          <a:bodyPr/>
+          <a:p/>
+        </p:txBody>
       </p:sp>
       <p:sp>
         <p:nvSpPr>
@@ -8178,6 +8502,10 @@
           </a:solidFill>
           <a:ln/>
         </p:spPr>
+        <p:txBody>
+          <a:bodyPr/>
+          <a:p/>
+        </p:txBody>
       </p:sp>
       <p:sp>
         <p:nvSpPr>
@@ -8283,6 +8611,10 @@
             </a:outerShdw>
           </a:effectLst>
         </p:spPr>
+        <p:txBody>
+          <a:bodyPr/>
+          <a:p/>
+        </p:txBody>
       </p:sp>
       <p:sp>
         <p:nvSpPr>
@@ -8303,6 +8635,10 @@
           </a:solidFill>
           <a:ln/>
         </p:spPr>
+        <p:txBody>
+          <a:bodyPr/>
+          <a:p/>
+        </p:txBody>
       </p:sp>
       <p:sp>
         <p:nvSpPr>
@@ -8408,6 +8744,10 @@
             </a:outerShdw>
           </a:effectLst>
         </p:spPr>
+        <p:txBody>
+          <a:bodyPr/>
+          <a:p/>
+        </p:txBody>
       </p:sp>
       <p:sp>
         <p:nvSpPr>
@@ -8428,6 +8768,10 @@
           </a:solidFill>
           <a:ln/>
         </p:spPr>
+        <p:txBody>
+          <a:bodyPr/>
+          <a:p/>
+        </p:txBody>
       </p:sp>
       <p:sp>
         <p:nvSpPr>
@@ -8533,6 +8877,10 @@
             </a:outerShdw>
           </a:effectLst>
         </p:spPr>
+        <p:txBody>
+          <a:bodyPr/>
+          <a:p/>
+        </p:txBody>
       </p:sp>
       <p:sp>
         <p:nvSpPr>
@@ -8553,6 +8901,10 @@
           </a:solidFill>
           <a:ln/>
         </p:spPr>
+        <p:txBody>
+          <a:bodyPr/>
+          <a:p/>
+        </p:txBody>
       </p:sp>
       <p:sp>
         <p:nvSpPr>
@@ -8612,6 +8964,10 @@
           </a:solidFill>
           <a:ln/>
         </p:spPr>
+        <p:txBody>
+          <a:bodyPr/>
+          <a:p/>
+        </p:txBody>
       </p:sp>
       <p:sp>
         <p:nvSpPr>
@@ -8703,6 +9059,10 @@
           </a:solidFill>
           <a:ln/>
         </p:spPr>
+        <p:txBody>
+          <a:bodyPr/>
+          <a:p/>
+        </p:txBody>
       </p:sp>
       <p:sp>
         <p:nvSpPr>
@@ -8801,6 +9161,10 @@
           </a:solidFill>
           <a:ln/>
         </p:spPr>
+        <p:txBody>
+          <a:bodyPr/>
+          <a:p/>
+        </p:txBody>
       </p:sp>
       <p:sp>
         <p:nvSpPr>
@@ -8821,6 +9185,10 @@
           </a:solidFill>
           <a:ln/>
         </p:spPr>
+        <p:txBody>
+          <a:bodyPr/>
+          <a:p/>
+        </p:txBody>
       </p:sp>
       <p:sp>
         <p:nvSpPr>
@@ -8958,6 +9326,10 @@
           </a:solidFill>
           <a:ln/>
         </p:spPr>
+        <p:txBody>
+          <a:bodyPr/>
+          <a:p/>
+        </p:txBody>
       </p:sp>
       <p:sp>
         <p:nvSpPr>
@@ -9095,6 +9467,10 @@
           </a:solidFill>
           <a:ln/>
         </p:spPr>
+        <p:txBody>
+          <a:bodyPr/>
+          <a:p/>
+        </p:txBody>
       </p:sp>
       <p:sp>
         <p:nvSpPr>
@@ -9232,6 +9608,10 @@
           </a:solidFill>
           <a:ln/>
         </p:spPr>
+        <p:txBody>
+          <a:bodyPr/>
+          <a:p/>
+        </p:txBody>
       </p:sp>
       <p:sp>
         <p:nvSpPr>
@@ -9369,6 +9749,10 @@
           </a:solidFill>
           <a:ln/>
         </p:spPr>
+        <p:txBody>
+          <a:bodyPr/>
+          <a:p/>
+        </p:txBody>
       </p:sp>
       <p:sp>
         <p:nvSpPr>
@@ -9409,6 +9793,30 @@
           </a:p>
         </p:txBody>
       </p:sp>
+      <p:pic>
+        <p:nvPicPr>
+          <p:cNvPr id="24" name="Picture 23" descr="story-ruflo-team.png"/>
+          <p:cNvPicPr>
+            <a:picLocks noChangeAspect="1"/>
+          </p:cNvPicPr>
+          <p:nvPr/>
+        </p:nvPicPr>
+        <p:blipFill>
+          <a:blip r:embed="rId3"/>
+          <a:stretch>
+            <a:fillRect/>
+          </a:stretch>
+        </p:blipFill>
+        <p:spPr>
+          <a:xfrm>
+            <a:off x="5029200" y="1371600"/>
+            <a:ext cx="3840480" cy="2560320"/>
+          </a:xfrm>
+          <a:prstGeom prst="rect">
+            <a:avLst/>
+          </a:prstGeom>
+        </p:spPr>
+      </p:pic>
     </p:spTree>
   </p:cSld>
   <p:clrMapOvr>
@@ -9460,6 +9868,10 @@
           </a:solidFill>
           <a:ln/>
         </p:spPr>
+        <p:txBody>
+          <a:bodyPr/>
+          <a:p/>
+        </p:txBody>
       </p:sp>
       <p:sp>
         <p:nvSpPr>
@@ -9565,6 +9977,10 @@
             </a:outerShdw>
           </a:effectLst>
         </p:spPr>
+        <p:txBody>
+          <a:bodyPr/>
+          <a:p/>
+        </p:txBody>
       </p:sp>
       <p:sp>
         <p:nvSpPr>
@@ -9585,6 +10001,10 @@
           </a:solidFill>
           <a:ln/>
         </p:spPr>
+        <p:txBody>
+          <a:bodyPr/>
+          <a:p/>
+        </p:txBody>
       </p:sp>
       <p:sp>
         <p:nvSpPr>
@@ -9763,6 +10183,10 @@
             </a:outerShdw>
           </a:effectLst>
         </p:spPr>
+        <p:txBody>
+          <a:bodyPr/>
+          <a:p/>
+        </p:txBody>
       </p:sp>
       <p:sp>
         <p:nvSpPr>
@@ -9783,6 +10207,10 @@
           </a:solidFill>
           <a:ln/>
         </p:spPr>
+        <p:txBody>
+          <a:bodyPr/>
+          <a:p/>
+        </p:txBody>
       </p:sp>
       <p:sp>
         <p:nvSpPr>
@@ -9961,6 +10389,10 @@
             </a:outerShdw>
           </a:effectLst>
         </p:spPr>
+        <p:txBody>
+          <a:bodyPr/>
+          <a:p/>
+        </p:txBody>
       </p:sp>
       <p:sp>
         <p:nvSpPr>
@@ -9981,6 +10413,10 @@
           </a:solidFill>
           <a:ln/>
         </p:spPr>
+        <p:txBody>
+          <a:bodyPr/>
+          <a:p/>
+        </p:txBody>
       </p:sp>
       <p:sp>
         <p:nvSpPr>
@@ -10159,6 +10595,10 @@
             </a:outerShdw>
           </a:effectLst>
         </p:spPr>
+        <p:txBody>
+          <a:bodyPr/>
+          <a:p/>
+        </p:txBody>
       </p:sp>
       <p:sp>
         <p:nvSpPr>
@@ -10179,6 +10619,10 @@
           </a:solidFill>
           <a:ln/>
         </p:spPr>
+        <p:txBody>
+          <a:bodyPr/>
+          <a:p/>
+        </p:txBody>
       </p:sp>
       <p:sp>
         <p:nvSpPr>
@@ -10350,6 +10794,10 @@
           </a:solidFill>
           <a:ln/>
         </p:spPr>
+        <p:txBody>
+          <a:bodyPr/>
+          <a:p/>
+        </p:txBody>
       </p:sp>
       <p:sp>
         <p:nvSpPr>
@@ -10448,6 +10896,10 @@
           </a:solidFill>
           <a:ln/>
         </p:spPr>
+        <p:txBody>
+          <a:bodyPr/>
+          <a:p/>
+        </p:txBody>
       </p:sp>
       <p:sp>
         <p:nvSpPr>
@@ -10488,6 +10940,30 @@
           </a:p>
         </p:txBody>
       </p:sp>
+      <p:pic>
+        <p:nvPicPr>
+          <p:cNvPr id="30" name="Picture 29" descr="deck-compression.png"/>
+          <p:cNvPicPr>
+            <a:picLocks noChangeAspect="1"/>
+          </p:cNvPicPr>
+          <p:nvPr/>
+        </p:nvPicPr>
+        <p:blipFill>
+          <a:blip r:embed="rId3"/>
+          <a:stretch>
+            <a:fillRect/>
+          </a:stretch>
+        </p:blipFill>
+        <p:spPr>
+          <a:xfrm>
+            <a:off x="5029200" y="1371600"/>
+            <a:ext cx="3840480" cy="2560320"/>
+          </a:xfrm>
+          <a:prstGeom prst="rect">
+            <a:avLst/>
+          </a:prstGeom>
+        </p:spPr>
+      </p:pic>
     </p:spTree>
   </p:cSld>
   <p:clrMapOvr>
@@ -10539,6 +11015,10 @@
           </a:solidFill>
           <a:ln/>
         </p:spPr>
+        <p:txBody>
+          <a:bodyPr/>
+          <a:p/>
+        </p:txBody>
       </p:sp>
       <p:sp>
         <p:nvSpPr>
@@ -10605,6 +11085,10 @@
             </a:outerShdw>
           </a:effectLst>
         </p:spPr>
+        <p:txBody>
+          <a:bodyPr/>
+          <a:p/>
+        </p:txBody>
       </p:sp>
       <p:sp>
         <p:nvSpPr>
@@ -10625,6 +11109,10 @@
           </a:solidFill>
           <a:ln/>
         </p:spPr>
+        <p:txBody>
+          <a:bodyPr/>
+          <a:p/>
+        </p:txBody>
       </p:sp>
       <p:sp>
         <p:nvSpPr>
@@ -10762,6 +11250,10 @@
           </a:solidFill>
           <a:ln/>
         </p:spPr>
+        <p:txBody>
+          <a:bodyPr/>
+          <a:p/>
+        </p:txBody>
       </p:sp>
       <p:sp>
         <p:nvSpPr>
@@ -10916,6 +11408,10 @@
             </a:outerShdw>
           </a:effectLst>
         </p:spPr>
+        <p:txBody>
+          <a:bodyPr/>
+          <a:p/>
+        </p:txBody>
       </p:sp>
       <p:sp>
         <p:nvSpPr>
@@ -10936,6 +11432,10 @@
           </a:solidFill>
           <a:ln/>
         </p:spPr>
+        <p:txBody>
+          <a:bodyPr/>
+          <a:p/>
+        </p:txBody>
       </p:sp>
       <p:sp>
         <p:nvSpPr>
@@ -11073,6 +11573,10 @@
           </a:solidFill>
           <a:ln/>
         </p:spPr>
+        <p:txBody>
+          <a:bodyPr/>
+          <a:p/>
+        </p:txBody>
       </p:sp>
       <p:sp>
         <p:nvSpPr>
@@ -11227,6 +11731,10 @@
             </a:outerShdw>
           </a:effectLst>
         </p:spPr>
+        <p:txBody>
+          <a:bodyPr/>
+          <a:p/>
+        </p:txBody>
       </p:sp>
       <p:sp>
         <p:nvSpPr>
@@ -11247,6 +11755,10 @@
           </a:solidFill>
           <a:ln/>
         </p:spPr>
+        <p:txBody>
+          <a:bodyPr/>
+          <a:p/>
+        </p:txBody>
       </p:sp>
       <p:sp>
         <p:nvSpPr>
@@ -11384,6 +11896,10 @@
           </a:solidFill>
           <a:ln/>
         </p:spPr>
+        <p:txBody>
+          <a:bodyPr/>
+          <a:p/>
+        </p:txBody>
       </p:sp>
       <p:sp>
         <p:nvSpPr>
@@ -11563,6 +12079,10 @@
           </a:solidFill>
           <a:ln/>
         </p:spPr>
+        <p:txBody>
+          <a:bodyPr/>
+          <a:p/>
+        </p:txBody>
       </p:sp>
       <p:sp>
         <p:nvSpPr>
@@ -11724,6 +12244,10 @@
             </a:outerShdw>
           </a:effectLst>
         </p:spPr>
+        <p:txBody>
+          <a:bodyPr/>
+          <a:p/>
+        </p:txBody>
       </p:sp>
       <p:sp>
         <p:nvSpPr>
@@ -11829,6 +12353,10 @@
             </a:outerShdw>
           </a:effectLst>
         </p:spPr>
+        <p:txBody>
+          <a:bodyPr/>
+          <a:p/>
+        </p:txBody>
       </p:sp>
       <p:sp>
         <p:nvSpPr>
@@ -11934,6 +12462,10 @@
             </a:outerShdw>
           </a:effectLst>
         </p:spPr>
+        <p:txBody>
+          <a:bodyPr/>
+          <a:p/>
+        </p:txBody>
       </p:sp>
       <p:sp>
         <p:nvSpPr>
@@ -12039,6 +12571,10 @@
             </a:outerShdw>
           </a:effectLst>
         </p:spPr>
+        <p:txBody>
+          <a:bodyPr/>
+          <a:p/>
+        </p:txBody>
       </p:sp>
       <p:sp>
         <p:nvSpPr>
@@ -12247,6 +12783,10 @@
           </a:solidFill>
           <a:ln/>
         </p:spPr>
+        <p:txBody>
+          <a:bodyPr/>
+          <a:p/>
+        </p:txBody>
       </p:sp>
       <p:sp>
         <p:nvSpPr>
@@ -12352,6 +12892,10 @@
             </a:outerShdw>
           </a:effectLst>
         </p:spPr>
+        <p:txBody>
+          <a:bodyPr/>
+          <a:p/>
+        </p:txBody>
       </p:sp>
       <p:sp>
         <p:nvSpPr>
@@ -12372,6 +12916,10 @@
           </a:solidFill>
           <a:ln/>
         </p:spPr>
+        <p:txBody>
+          <a:bodyPr/>
+          <a:p/>
+        </p:txBody>
       </p:sp>
       <p:sp>
         <p:nvSpPr>
@@ -12477,6 +13025,10 @@
             </a:outerShdw>
           </a:effectLst>
         </p:spPr>
+        <p:txBody>
+          <a:bodyPr/>
+          <a:p/>
+        </p:txBody>
       </p:sp>
       <p:sp>
         <p:nvSpPr>
@@ -12497,6 +13049,10 @@
           </a:solidFill>
           <a:ln/>
         </p:spPr>
+        <p:txBody>
+          <a:bodyPr/>
+          <a:p/>
+        </p:txBody>
       </p:sp>
       <p:sp>
         <p:nvSpPr>
@@ -12602,6 +13158,10 @@
             </a:outerShdw>
           </a:effectLst>
         </p:spPr>
+        <p:txBody>
+          <a:bodyPr/>
+          <a:p/>
+        </p:txBody>
       </p:sp>
       <p:sp>
         <p:nvSpPr>
@@ -12622,6 +13182,10 @@
           </a:solidFill>
           <a:ln/>
         </p:spPr>
+        <p:txBody>
+          <a:bodyPr/>
+          <a:p/>
+        </p:txBody>
       </p:sp>
       <p:sp>
         <p:nvSpPr>
@@ -12727,6 +13291,10 @@
             </a:outerShdw>
           </a:effectLst>
         </p:spPr>
+        <p:txBody>
+          <a:bodyPr/>
+          <a:p/>
+        </p:txBody>
       </p:sp>
       <p:sp>
         <p:nvSpPr>
@@ -12747,6 +13315,10 @@
           </a:solidFill>
           <a:ln/>
         </p:spPr>
+        <p:txBody>
+          <a:bodyPr/>
+          <a:p/>
+        </p:txBody>
       </p:sp>
       <p:sp>
         <p:nvSpPr>
@@ -12852,6 +13424,10 @@
             </a:outerShdw>
           </a:effectLst>
         </p:spPr>
+        <p:txBody>
+          <a:bodyPr/>
+          <a:p/>
+        </p:txBody>
       </p:sp>
       <p:sp>
         <p:nvSpPr>
@@ -12872,6 +13448,10 @@
           </a:solidFill>
           <a:ln/>
         </p:spPr>
+        <p:txBody>
+          <a:bodyPr/>
+          <a:p/>
+        </p:txBody>
       </p:sp>
       <p:sp>
         <p:nvSpPr>
@@ -12977,6 +13557,10 @@
             </a:outerShdw>
           </a:effectLst>
         </p:spPr>
+        <p:txBody>
+          <a:bodyPr/>
+          <a:p/>
+        </p:txBody>
       </p:sp>
       <p:sp>
         <p:nvSpPr>
@@ -12997,6 +13581,10 @@
           </a:solidFill>
           <a:ln/>
         </p:spPr>
+        <p:txBody>
+          <a:bodyPr/>
+          <a:p/>
+        </p:txBody>
       </p:sp>
       <p:sp>
         <p:nvSpPr>
@@ -13095,6 +13683,10 @@
           </a:solidFill>
           <a:ln/>
         </p:spPr>
+        <p:txBody>
+          <a:bodyPr/>
+          <a:p/>
+        </p:txBody>
       </p:sp>
       <p:sp>
         <p:nvSpPr>
@@ -13186,6 +13778,10 @@
           </a:solidFill>
           <a:ln/>
         </p:spPr>
+        <p:txBody>
+          <a:bodyPr/>
+          <a:p/>
+        </p:txBody>
       </p:sp>
       <p:sp>
         <p:nvSpPr>
@@ -16769,6 +17365,10 @@
           </a:solidFill>
           <a:ln/>
         </p:spPr>
+        <p:txBody>
+          <a:bodyPr/>
+          <a:p/>
+        </p:txBody>
       </p:sp>
       <p:sp>
         <p:nvSpPr>
@@ -16900,6 +17500,10 @@
             </a:outerShdw>
           </a:effectLst>
         </p:spPr>
+        <p:txBody>
+          <a:bodyPr/>
+          <a:p/>
+        </p:txBody>
       </p:sp>
       <p:sp>
         <p:nvSpPr>
@@ -16920,6 +17524,10 @@
           </a:solidFill>
           <a:ln/>
         </p:spPr>
+        <p:txBody>
+          <a:bodyPr/>
+          <a:p/>
+        </p:txBody>
       </p:sp>
       <p:sp>
         <p:nvSpPr>
@@ -17120,6 +17728,10 @@
             </a:outerShdw>
           </a:effectLst>
         </p:spPr>
+        <p:txBody>
+          <a:bodyPr/>
+          <a:p/>
+        </p:txBody>
       </p:sp>
       <p:sp>
         <p:nvSpPr>
@@ -17140,6 +17752,10 @@
           </a:solidFill>
           <a:ln/>
         </p:spPr>
+        <p:txBody>
+          <a:bodyPr/>
+          <a:p/>
+        </p:txBody>
       </p:sp>
       <p:sp>
         <p:nvSpPr>
@@ -17340,6 +17956,10 @@
             </a:outerShdw>
           </a:effectLst>
         </p:spPr>
+        <p:txBody>
+          <a:bodyPr/>
+          <a:p/>
+        </p:txBody>
       </p:sp>
       <p:sp>
         <p:nvSpPr>
@@ -17360,6 +17980,10 @@
           </a:solidFill>
           <a:ln/>
         </p:spPr>
+        <p:txBody>
+          <a:bodyPr/>
+          <a:p/>
+        </p:txBody>
       </p:sp>
       <p:sp>
         <p:nvSpPr>
@@ -17560,6 +18184,10 @@
             </a:outerShdw>
           </a:effectLst>
         </p:spPr>
+        <p:txBody>
+          <a:bodyPr/>
+          <a:p/>
+        </p:txBody>
       </p:sp>
       <p:sp>
         <p:nvSpPr>
@@ -17580,6 +18208,10 @@
           </a:solidFill>
           <a:ln/>
         </p:spPr>
+        <p:txBody>
+          <a:bodyPr/>
+          <a:p/>
+        </p:txBody>
       </p:sp>
       <p:sp>
         <p:nvSpPr>
@@ -17780,6 +18412,10 @@
             </a:outerShdw>
           </a:effectLst>
         </p:spPr>
+        <p:txBody>
+          <a:bodyPr/>
+          <a:p/>
+        </p:txBody>
       </p:sp>
       <p:sp>
         <p:nvSpPr>
@@ -17800,6 +18436,10 @@
           </a:solidFill>
           <a:ln/>
         </p:spPr>
+        <p:txBody>
+          <a:bodyPr/>
+          <a:p/>
+        </p:txBody>
       </p:sp>
       <p:sp>
         <p:nvSpPr>
@@ -18000,6 +18640,10 @@
             </a:outerShdw>
           </a:effectLst>
         </p:spPr>
+        <p:txBody>
+          <a:bodyPr/>
+          <a:p/>
+        </p:txBody>
       </p:sp>
       <p:sp>
         <p:nvSpPr>
@@ -18020,6 +18664,10 @@
           </a:solidFill>
           <a:ln/>
         </p:spPr>
+        <p:txBody>
+          <a:bodyPr/>
+          <a:p/>
+        </p:txBody>
       </p:sp>
       <p:sp>
         <p:nvSpPr>
@@ -18194,6 +18842,30 @@
           </a:p>
         </p:txBody>
       </p:sp>
+      <p:pic>
+        <p:nvPicPr>
+          <p:cNvPr id="42" name="Picture 41" descr="hero-ecosystem.png"/>
+          <p:cNvPicPr>
+            <a:picLocks noChangeAspect="1"/>
+          </p:cNvPicPr>
+          <p:nvPr/>
+        </p:nvPicPr>
+        <p:blipFill>
+          <a:blip r:embed="rId4"/>
+          <a:stretch>
+            <a:fillRect/>
+          </a:stretch>
+        </p:blipFill>
+        <p:spPr>
+          <a:xfrm>
+            <a:off x="5029200" y="1371600"/>
+            <a:ext cx="3840480" cy="2560320"/>
+          </a:xfrm>
+          <a:prstGeom prst="rect">
+            <a:avLst/>
+          </a:prstGeom>
+        </p:spPr>
+      </p:pic>
     </p:spTree>
   </p:cSld>
   <p:clrMapOvr>
@@ -18245,6 +18917,10 @@
           </a:solidFill>
           <a:ln/>
         </p:spPr>
+        <p:txBody>
+          <a:bodyPr/>
+          <a:p/>
+        </p:txBody>
       </p:sp>
       <p:sp>
         <p:nvSpPr>
@@ -18265,6 +18941,10 @@
           </a:solidFill>
           <a:ln/>
         </p:spPr>
+        <p:txBody>
+          <a:bodyPr/>
+          <a:p/>
+        </p:txBody>
       </p:sp>
       <p:sp>
         <p:nvSpPr>
@@ -18409,6 +19089,10 @@
             </a:outerShdw>
           </a:effectLst>
         </p:spPr>
+        <p:txBody>
+          <a:bodyPr/>
+          <a:p/>
+        </p:txBody>
       </p:sp>
       <p:sp>
         <p:nvSpPr>
@@ -18429,6 +19113,10 @@
           </a:solidFill>
           <a:ln/>
         </p:spPr>
+        <p:txBody>
+          <a:bodyPr/>
+          <a:p/>
+        </p:txBody>
       </p:sp>
       <p:sp>
         <p:nvSpPr>
@@ -18449,6 +19137,10 @@
           </a:solidFill>
           <a:ln/>
         </p:spPr>
+        <p:txBody>
+          <a:bodyPr/>
+          <a:p/>
+        </p:txBody>
       </p:sp>
       <p:sp>
         <p:nvSpPr>
@@ -18547,6 +19239,10 @@
           </a:solidFill>
           <a:ln/>
         </p:spPr>
+        <p:txBody>
+          <a:bodyPr/>
+          <a:p/>
+        </p:txBody>
       </p:sp>
       <p:sp>
         <p:nvSpPr>
@@ -18645,6 +19341,10 @@
           </a:solidFill>
           <a:ln/>
         </p:spPr>
+        <p:txBody>
+          <a:bodyPr/>
+          <a:p/>
+        </p:txBody>
       </p:sp>
       <p:sp>
         <p:nvSpPr>
@@ -18743,6 +19443,10 @@
           </a:solidFill>
           <a:ln/>
         </p:spPr>
+        <p:txBody>
+          <a:bodyPr/>
+          <a:p/>
+        </p:txBody>
       </p:sp>
       <p:sp>
         <p:nvSpPr>
@@ -18841,6 +19545,10 @@
           </a:solidFill>
           <a:ln/>
         </p:spPr>
+        <p:txBody>
+          <a:bodyPr/>
+          <a:p/>
+        </p:txBody>
       </p:sp>
       <p:sp>
         <p:nvSpPr>
@@ -18881,6 +19589,30 @@
           </a:p>
         </p:txBody>
       </p:sp>
+      <p:pic>
+        <p:nvPicPr>
+          <p:cNvPr id="23" name="Picture 22" descr="story-pi-brain.png"/>
+          <p:cNvPicPr>
+            <a:picLocks noChangeAspect="1"/>
+          </p:cNvPicPr>
+          <p:nvPr/>
+        </p:nvPicPr>
+        <p:blipFill>
+          <a:blip r:embed="rId3"/>
+          <a:stretch>
+            <a:fillRect/>
+          </a:stretch>
+        </p:blipFill>
+        <p:spPr>
+          <a:xfrm>
+            <a:off x="5029200" y="1371600"/>
+            <a:ext cx="3840480" cy="2560320"/>
+          </a:xfrm>
+          <a:prstGeom prst="rect">
+            <a:avLst/>
+          </a:prstGeom>
+        </p:spPr>
+      </p:pic>
     </p:spTree>
   </p:cSld>
   <p:clrMapOvr>
@@ -18932,6 +19664,10 @@
           </a:solidFill>
           <a:ln/>
         </p:spPr>
+        <p:txBody>
+          <a:bodyPr/>
+          <a:p/>
+        </p:txBody>
       </p:sp>
       <p:sp>
         <p:nvSpPr>
@@ -19024,6 +19760,10 @@
             </a:outerShdw>
           </a:effectLst>
         </p:spPr>
+        <p:txBody>
+          <a:bodyPr/>
+          <a:p/>
+        </p:txBody>
       </p:sp>
       <p:sp>
         <p:nvSpPr>
@@ -19044,6 +19784,10 @@
           </a:solidFill>
           <a:ln/>
         </p:spPr>
+        <p:txBody>
+          <a:bodyPr/>
+          <a:p/>
+        </p:txBody>
       </p:sp>
       <p:sp>
         <p:nvSpPr>
@@ -19245,6 +19989,10 @@
             </a:outerShdw>
           </a:effectLst>
         </p:spPr>
+        <p:txBody>
+          <a:bodyPr/>
+          <a:p/>
+        </p:txBody>
       </p:sp>
       <p:sp>
         <p:nvSpPr>
@@ -19265,6 +20013,10 @@
           </a:solidFill>
           <a:ln/>
         </p:spPr>
+        <p:txBody>
+          <a:bodyPr/>
+          <a:p/>
+        </p:txBody>
       </p:sp>
       <p:sp>
         <p:nvSpPr>
@@ -19459,6 +20211,10 @@
           </a:solidFill>
           <a:ln/>
         </p:spPr>
+        <p:txBody>
+          <a:bodyPr/>
+          <a:p/>
+        </p:txBody>
       </p:sp>
       <p:sp>
         <p:nvSpPr>
@@ -19555,6 +20311,30 @@
           </a:p>
         </p:txBody>
       </p:sp>
+      <p:pic>
+        <p:nvPicPr>
+          <p:cNvPr id="16" name="Picture 15" descr="story-aimds-security.png"/>
+          <p:cNvPicPr>
+            <a:picLocks noChangeAspect="1"/>
+          </p:cNvPicPr>
+          <p:nvPr/>
+        </p:nvPicPr>
+        <p:blipFill>
+          <a:blip r:embed="rId4"/>
+          <a:stretch>
+            <a:fillRect/>
+          </a:stretch>
+        </p:blipFill>
+        <p:spPr>
+          <a:xfrm>
+            <a:off x="5029200" y="1371600"/>
+            <a:ext cx="3840480" cy="2560320"/>
+          </a:xfrm>
+          <a:prstGeom prst="rect">
+            <a:avLst/>
+          </a:prstGeom>
+        </p:spPr>
+      </p:pic>
     </p:spTree>
   </p:cSld>
   <p:clrMapOvr>
@@ -19606,6 +20386,10 @@
           </a:solidFill>
           <a:ln/>
         </p:spPr>
+        <p:txBody>
+          <a:bodyPr/>
+          <a:p/>
+        </p:txBody>
       </p:sp>
       <p:sp>
         <p:nvSpPr>
@@ -19682,6 +20466,10 @@
           </a:solidFill>
           <a:ln/>
         </p:spPr>
+        <p:txBody>
+          <a:bodyPr/>
+          <a:p/>
+        </p:txBody>
       </p:sp>
       <p:sp>
         <p:nvSpPr>
@@ -19943,6 +20731,10 @@
             </a:outerShdw>
           </a:effectLst>
         </p:spPr>
+        <p:txBody>
+          <a:bodyPr/>
+          <a:p/>
+        </p:txBody>
       </p:sp>
       <p:sp>
         <p:nvSpPr>
@@ -19963,6 +20755,10 @@
           </a:solidFill>
           <a:ln/>
         </p:spPr>
+        <p:txBody>
+          <a:bodyPr/>
+          <a:p/>
+        </p:txBody>
       </p:sp>
       <p:sp>
         <p:nvSpPr>
@@ -20107,6 +20903,10 @@
             </a:outerShdw>
           </a:effectLst>
         </p:spPr>
+        <p:txBody>
+          <a:bodyPr/>
+          <a:p/>
+        </p:txBody>
       </p:sp>
       <p:sp>
         <p:nvSpPr>
@@ -20127,6 +20927,10 @@
           </a:solidFill>
           <a:ln/>
         </p:spPr>
+        <p:txBody>
+          <a:bodyPr/>
+          <a:p/>
+        </p:txBody>
       </p:sp>
       <p:sp>
         <p:nvSpPr>
@@ -20271,6 +21075,10 @@
             </a:outerShdw>
           </a:effectLst>
         </p:spPr>
+        <p:txBody>
+          <a:bodyPr/>
+          <a:p/>
+        </p:txBody>
       </p:sp>
       <p:sp>
         <p:nvSpPr>
@@ -20291,6 +21099,10 @@
           </a:solidFill>
           <a:ln/>
         </p:spPr>
+        <p:txBody>
+          <a:bodyPr/>
+          <a:p/>
+        </p:txBody>
       </p:sp>
       <p:sp>
         <p:nvSpPr>
@@ -20435,6 +21247,10 @@
             </a:outerShdw>
           </a:effectLst>
         </p:spPr>
+        <p:txBody>
+          <a:bodyPr/>
+          <a:p/>
+        </p:txBody>
       </p:sp>
       <p:sp>
         <p:nvSpPr>
@@ -20455,6 +21271,10 @@
           </a:solidFill>
           <a:ln/>
         </p:spPr>
+        <p:txBody>
+          <a:bodyPr/>
+          <a:p/>
+        </p:txBody>
       </p:sp>
       <p:sp>
         <p:nvSpPr>
@@ -20599,6 +21419,10 @@
             </a:outerShdw>
           </a:effectLst>
         </p:spPr>
+        <p:txBody>
+          <a:bodyPr/>
+          <a:p/>
+        </p:txBody>
       </p:sp>
       <p:sp>
         <p:nvSpPr>
@@ -20619,6 +21443,10 @@
           </a:solidFill>
           <a:ln/>
         </p:spPr>
+        <p:txBody>
+          <a:bodyPr/>
+          <a:p/>
+        </p:txBody>
       </p:sp>
       <p:sp>
         <p:nvSpPr>
@@ -20763,6 +21591,10 @@
             </a:outerShdw>
           </a:effectLst>
         </p:spPr>
+        <p:txBody>
+          <a:bodyPr/>
+          <a:p/>
+        </p:txBody>
       </p:sp>
       <p:sp>
         <p:nvSpPr>
@@ -20783,6 +21615,10 @@
           </a:solidFill>
           <a:ln/>
         </p:spPr>
+        <p:txBody>
+          <a:bodyPr/>
+          <a:p/>
+        </p:txBody>
       </p:sp>
       <p:sp>
         <p:nvSpPr>
@@ -20940,6 +21776,30 @@
           </a:p>
         </p:txBody>
       </p:sp>
+      <p:pic>
+        <p:nvPicPr>
+          <p:cNvPr id="42" name="Picture 41" descr="deck-compression.png"/>
+          <p:cNvPicPr>
+            <a:picLocks noChangeAspect="1"/>
+          </p:cNvPicPr>
+          <p:nvPr/>
+        </p:nvPicPr>
+        <p:blipFill>
+          <a:blip r:embed="rId3"/>
+          <a:stretch>
+            <a:fillRect/>
+          </a:stretch>
+        </p:blipFill>
+        <p:spPr>
+          <a:xfrm>
+            <a:off x="5029200" y="1371600"/>
+            <a:ext cx="3840480" cy="2560320"/>
+          </a:xfrm>
+          <a:prstGeom prst="rect">
+            <a:avLst/>
+          </a:prstGeom>
+        </p:spPr>
+      </p:pic>
     </p:spTree>
   </p:cSld>
   <p:clrMapOvr>
@@ -20991,6 +21851,10 @@
           </a:solidFill>
           <a:ln/>
         </p:spPr>
+        <p:txBody>
+          <a:bodyPr/>
+          <a:p/>
+        </p:txBody>
       </p:sp>
       <p:sp>
         <p:nvSpPr>
@@ -21096,6 +21960,10 @@
             </a:outerShdw>
           </a:effectLst>
         </p:spPr>
+        <p:txBody>
+          <a:bodyPr/>
+          <a:p/>
+        </p:txBody>
       </p:sp>
       <p:sp>
         <p:nvSpPr>
@@ -21116,6 +21984,10 @@
           </a:solidFill>
           <a:ln/>
         </p:spPr>
+        <p:txBody>
+          <a:bodyPr/>
+          <a:p/>
+        </p:txBody>
       </p:sp>
       <p:sp>
         <p:nvSpPr>
@@ -21338,6 +22210,10 @@
             </a:outerShdw>
           </a:effectLst>
         </p:spPr>
+        <p:txBody>
+          <a:bodyPr/>
+          <a:p/>
+        </p:txBody>
       </p:sp>
       <p:sp>
         <p:nvSpPr>
@@ -21358,6 +22234,10 @@
           </a:solidFill>
           <a:ln/>
         </p:spPr>
+        <p:txBody>
+          <a:bodyPr/>
+          <a:p/>
+        </p:txBody>
       </p:sp>
       <p:sp>
         <p:nvSpPr>
@@ -21580,6 +22460,10 @@
             </a:outerShdw>
           </a:effectLst>
         </p:spPr>
+        <p:txBody>
+          <a:bodyPr/>
+          <a:p/>
+        </p:txBody>
       </p:sp>
       <p:sp>
         <p:nvSpPr>
@@ -21600,6 +22484,10 @@
           </a:solidFill>
           <a:ln/>
         </p:spPr>
+        <p:txBody>
+          <a:bodyPr/>
+          <a:p/>
+        </p:txBody>
       </p:sp>
       <p:sp>
         <p:nvSpPr>
@@ -21822,6 +22710,10 @@
             </a:outerShdw>
           </a:effectLst>
         </p:spPr>
+        <p:txBody>
+          <a:bodyPr/>
+          <a:p/>
+        </p:txBody>
       </p:sp>
       <p:sp>
         <p:nvSpPr>
@@ -21842,6 +22734,10 @@
           </a:solidFill>
           <a:ln/>
         </p:spPr>
+        <p:txBody>
+          <a:bodyPr/>
+          <a:p/>
+        </p:txBody>
       </p:sp>
       <p:sp>
         <p:nvSpPr>
@@ -22057,6 +22953,10 @@
           </a:solidFill>
           <a:ln/>
         </p:spPr>
+        <p:txBody>
+          <a:bodyPr/>
+          <a:p/>
+        </p:txBody>
       </p:sp>
       <p:sp>
         <p:nvSpPr>
@@ -22155,6 +23055,10 @@
           </a:solidFill>
           <a:ln/>
         </p:spPr>
+        <p:txBody>
+          <a:bodyPr/>
+          <a:p/>
+        </p:txBody>
       </p:sp>
       <p:sp>
         <p:nvSpPr>
@@ -22253,6 +23157,10 @@
           </a:solidFill>
           <a:ln/>
         </p:spPr>
+        <p:txBody>
+          <a:bodyPr/>
+          <a:p/>
+        </p:txBody>
       </p:sp>
       <p:sp>
         <p:nvSpPr>
@@ -22383,6 +23291,10 @@
           </a:solidFill>
           <a:ln/>
         </p:spPr>
+        <p:txBody>
+          <a:bodyPr/>
+          <a:p/>
+        </p:txBody>
       </p:sp>
       <p:sp>
         <p:nvSpPr>
@@ -24705,6 +25617,10 @@
           </a:solidFill>
           <a:ln/>
         </p:spPr>
+        <p:txBody>
+          <a:bodyPr/>
+          <a:p/>
+        </p:txBody>
       </p:sp>
       <p:sp>
         <p:nvSpPr>
@@ -24745,6 +25661,30 @@
           </a:p>
         </p:txBody>
       </p:sp>
+      <p:pic>
+        <p:nvPicPr>
+          <p:cNvPr id="11" name="Picture 10" descr="deck-speed-comparison.png"/>
+          <p:cNvPicPr>
+            <a:picLocks noChangeAspect="1"/>
+          </p:cNvPicPr>
+          <p:nvPr/>
+        </p:nvPicPr>
+        <p:blipFill>
+          <a:blip r:embed="rId3"/>
+          <a:stretch>
+            <a:fillRect/>
+          </a:stretch>
+        </p:blipFill>
+        <p:spPr>
+          <a:xfrm>
+            <a:off x="5029200" y="1371600"/>
+            <a:ext cx="3840480" cy="2560320"/>
+          </a:xfrm>
+          <a:prstGeom prst="rect">
+            <a:avLst/>
+          </a:prstGeom>
+        </p:spPr>
+      </p:pic>
     </p:spTree>
   </p:cSld>
   <p:clrMapOvr>

</xml_diff>